<commit_message>
Print PPTX: drop grill accent line, remove ₮ (rendered as tofu box)
- Grill PPTX: remove "◆ ШОРЛОГ ГАЗАР ◆" line
- All 3 PPTX (grill, sets, main menu): drop the ₮ symbol (missing glyph
  showed as an empty box in the user's fonts); prices now plain numbers with
  a "Үнэ төгрөгөөр" currency note in the footer

Co-Authored-By: Claude Opus 4.8 <noreply@anthropic.com>
Claude-Session: https://claude.ai/code/session_01TnVy1C21x68ctXsvvdvyLV
</commit_message>
<xml_diff>
--- a/print/C-Garden-Grill-A4.pptx
+++ b/print/C-Garden-Grill-A4.pptx
@@ -3212,7 +3212,7 @@
         </p:nvSpPr>
         <p:spPr>
           <a:xfrm>
-            <a:off x="548640" y="4343400"/>
+            <a:off x="548640" y="4526280"/>
             <a:ext cx="6464808" cy="365760"/>
           </a:xfrm>
           <a:prstGeom prst="rect">
@@ -3247,7 +3247,7 @@
         </p:nvSpPr>
         <p:spPr>
           <a:xfrm>
-            <a:off x="548640" y="4681728"/>
+            <a:off x="548640" y="4864608"/>
             <a:ext cx="6464808" cy="914400"/>
           </a:xfrm>
           <a:prstGeom prst="rect">
@@ -3282,42 +3282,7 @@
         </p:nvSpPr>
         <p:spPr>
           <a:xfrm>
-            <a:off x="548640" y="5650992"/>
-            <a:ext cx="6464808" cy="274320"/>
-          </a:xfrm>
-          <a:prstGeom prst="rect">
-            <a:avLst/>
-          </a:prstGeom>
-          <a:noFill/>
-        </p:spPr>
-        <p:txBody>
-          <a:bodyPr wrap="square" lIns="0" rIns="0" tIns="0" bIns="0">
-            <a:spAutoFit/>
-          </a:bodyPr>
-          <a:lstStyle/>
-          <a:p>
-            <a:pPr algn="ctr"/>
-            <a:r>
-              <a:rPr sz="1000">
-                <a:solidFill>
-                  <a:srgbClr val="53C992"/>
-                </a:solidFill>
-                <a:latin typeface="Arial"/>
-              </a:rPr>
-              <a:t>◆  ШОРЛОГ ГАЗАР  ◆</a:t>
-            </a:r>
-          </a:p>
-        </p:txBody>
-      </p:sp>
-      <p:sp>
-        <p:nvSpPr>
-          <p:cNvPr id="8" name="TextBox 7"/>
-          <p:cNvSpPr txBox="1"/>
-          <p:nvPr/>
-        </p:nvSpPr>
-        <p:spPr>
-          <a:xfrm>
-            <a:off x="868680" y="6080760"/>
+            <a:off x="868680" y="5989320"/>
             <a:ext cx="5824728" cy="4023360"/>
           </a:xfrm>
           <a:prstGeom prst="rect">
@@ -3383,7 +3348,7 @@
                 </a:solidFill>
                 <a:latin typeface="Georgia"/>
               </a:rPr>
-              <a:t>	40,000₮</a:t>
+              <a:t>	40,000</a:t>
             </a:r>
           </a:p>
           <a:p>
@@ -3423,7 +3388,7 @@
                 </a:solidFill>
                 <a:latin typeface="Georgia"/>
               </a:rPr>
-              <a:t>	36,000₮</a:t>
+              <a:t>	36,000</a:t>
             </a:r>
           </a:p>
           <a:p>
@@ -3463,7 +3428,7 @@
                 </a:solidFill>
                 <a:latin typeface="Georgia"/>
               </a:rPr>
-              <a:t>	30,000₮</a:t>
+              <a:t>	30,000</a:t>
             </a:r>
           </a:p>
           <a:p>
@@ -3522,7 +3487,7 @@
                 </a:solidFill>
                 <a:latin typeface="Georgia"/>
               </a:rPr>
-              <a:t>	28,000₮</a:t>
+              <a:t>	28,000</a:t>
             </a:r>
           </a:p>
           <a:p>
@@ -3562,7 +3527,7 @@
                 </a:solidFill>
                 <a:latin typeface="Georgia"/>
               </a:rPr>
-              <a:t>	120,000₮</a:t>
+              <a:t>	120,000</a:t>
             </a:r>
           </a:p>
           <a:p>
@@ -3602,7 +3567,7 @@
                 </a:solidFill>
                 <a:latin typeface="Georgia"/>
               </a:rPr>
-              <a:t>	15,000₮</a:t>
+              <a:t>	15,000</a:t>
             </a:r>
           </a:p>
           <a:p>
@@ -3642,14 +3607,14 @@
                 </a:solidFill>
                 <a:latin typeface="Georgia"/>
               </a:rPr>
-              <a:t>	21,000₮</a:t>
-            </a:r>
-          </a:p>
-        </p:txBody>
-      </p:sp>
-      <p:sp>
-        <p:nvSpPr>
-          <p:cNvPr id="9" name="TextBox 8"/>
+              <a:t>	21,000</a:t>
+            </a:r>
+          </a:p>
+        </p:txBody>
+      </p:sp>
+      <p:sp>
+        <p:nvSpPr>
+          <p:cNvPr id="8" name="TextBox 7"/>
           <p:cNvSpPr txBox="1"/>
           <p:nvPr/>
         </p:nvSpPr>
@@ -3677,7 +3642,7 @@
                 </a:solidFill>
                 <a:latin typeface="Arial"/>
               </a:rPr>
-              <a:t>Бүх үнэ ₮  ·  НӨАТ болон хотын татвар багтсан</a:t>
+              <a:t>Үнэ төгрөгөөр  ·  НӨАТ болон хотын татвар багтсан</a:t>
             </a:r>
           </a:p>
         </p:txBody>

</xml_diff>